<commit_message>
feat(IDEA): pptx & pdf files updated
</commit_message>
<xml_diff>
--- a/Splunk-Build-A-Thon-Idea/Splunk-DNSGuard-AI-IDEA.pptx
+++ b/Splunk-Build-A-Thon-Idea/Splunk-DNSGuard-AI-IDEA.pptx
@@ -205,7 +205,7 @@
           <a:p>
             <a:fld id="{07B3BC97-3BC0-40FA-81A1-72ED287ACE70}" type="datetimeFigureOut">
               <a:rPr lang="it-IT" smtClean="0"/>
-              <a:t>24/05/2025</a:t>
+              <a:t>25/05/2025</a:t>
             </a:fld>
             <a:endParaRPr lang="it-IT" dirty="0"/>
           </a:p>
@@ -703,7 +703,7 @@
           <a:p>
             <a:fld id="{C94D923A-9170-4643-B378-C6ADCBE8E107}" type="datetimeFigureOut">
               <a:rPr lang="it-IT" smtClean="0"/>
-              <a:t>24/05/2025</a:t>
+              <a:t>25/05/2025</a:t>
             </a:fld>
             <a:endParaRPr lang="it-IT" dirty="0"/>
           </a:p>
@@ -901,7 +901,7 @@
           <a:p>
             <a:fld id="{C94D923A-9170-4643-B378-C6ADCBE8E107}" type="datetimeFigureOut">
               <a:rPr lang="it-IT" smtClean="0"/>
-              <a:t>24/05/2025</a:t>
+              <a:t>25/05/2025</a:t>
             </a:fld>
             <a:endParaRPr lang="it-IT" dirty="0"/>
           </a:p>
@@ -1109,7 +1109,7 @@
           <a:p>
             <a:fld id="{C94D923A-9170-4643-B378-C6ADCBE8E107}" type="datetimeFigureOut">
               <a:rPr lang="it-IT" smtClean="0"/>
-              <a:t>24/05/2025</a:t>
+              <a:t>25/05/2025</a:t>
             </a:fld>
             <a:endParaRPr lang="it-IT" dirty="0"/>
           </a:p>
@@ -1307,7 +1307,7 @@
           <a:p>
             <a:fld id="{C94D923A-9170-4643-B378-C6ADCBE8E107}" type="datetimeFigureOut">
               <a:rPr lang="it-IT" smtClean="0"/>
-              <a:t>24/05/2025</a:t>
+              <a:t>25/05/2025</a:t>
             </a:fld>
             <a:endParaRPr lang="it-IT" dirty="0"/>
           </a:p>
@@ -1582,7 +1582,7 @@
           <a:p>
             <a:fld id="{C94D923A-9170-4643-B378-C6ADCBE8E107}" type="datetimeFigureOut">
               <a:rPr lang="it-IT" smtClean="0"/>
-              <a:t>24/05/2025</a:t>
+              <a:t>25/05/2025</a:t>
             </a:fld>
             <a:endParaRPr lang="it-IT" dirty="0"/>
           </a:p>
@@ -1847,7 +1847,7 @@
           <a:p>
             <a:fld id="{C94D923A-9170-4643-B378-C6ADCBE8E107}" type="datetimeFigureOut">
               <a:rPr lang="it-IT" smtClean="0"/>
-              <a:t>24/05/2025</a:t>
+              <a:t>25/05/2025</a:t>
             </a:fld>
             <a:endParaRPr lang="it-IT" dirty="0"/>
           </a:p>
@@ -2259,7 +2259,7 @@
           <a:p>
             <a:fld id="{C94D923A-9170-4643-B378-C6ADCBE8E107}" type="datetimeFigureOut">
               <a:rPr lang="it-IT" smtClean="0"/>
-              <a:t>24/05/2025</a:t>
+              <a:t>25/05/2025</a:t>
             </a:fld>
             <a:endParaRPr lang="it-IT" dirty="0"/>
           </a:p>
@@ -2400,7 +2400,7 @@
           <a:p>
             <a:fld id="{C94D923A-9170-4643-B378-C6ADCBE8E107}" type="datetimeFigureOut">
               <a:rPr lang="it-IT" smtClean="0"/>
-              <a:t>24/05/2025</a:t>
+              <a:t>25/05/2025</a:t>
             </a:fld>
             <a:endParaRPr lang="it-IT" dirty="0"/>
           </a:p>
@@ -2513,7 +2513,7 @@
           <a:p>
             <a:fld id="{C94D923A-9170-4643-B378-C6ADCBE8E107}" type="datetimeFigureOut">
               <a:rPr lang="it-IT" smtClean="0"/>
-              <a:t>24/05/2025</a:t>
+              <a:t>25/05/2025</a:t>
             </a:fld>
             <a:endParaRPr lang="it-IT" dirty="0"/>
           </a:p>
@@ -2824,7 +2824,7 @@
           <a:p>
             <a:fld id="{C94D923A-9170-4643-B378-C6ADCBE8E107}" type="datetimeFigureOut">
               <a:rPr lang="it-IT" smtClean="0"/>
-              <a:t>24/05/2025</a:t>
+              <a:t>25/05/2025</a:t>
             </a:fld>
             <a:endParaRPr lang="it-IT" dirty="0"/>
           </a:p>
@@ -3112,7 +3112,7 @@
           <a:p>
             <a:fld id="{C94D923A-9170-4643-B378-C6ADCBE8E107}" type="datetimeFigureOut">
               <a:rPr lang="it-IT" smtClean="0"/>
-              <a:t>24/05/2025</a:t>
+              <a:t>25/05/2025</a:t>
             </a:fld>
             <a:endParaRPr lang="it-IT" dirty="0"/>
           </a:p>
@@ -3353,7 +3353,7 @@
           <a:p>
             <a:fld id="{C94D923A-9170-4643-B378-C6ADCBE8E107}" type="datetimeFigureOut">
               <a:rPr lang="it-IT" smtClean="0"/>
-              <a:t>24/05/2025</a:t>
+              <a:t>25/05/2025</a:t>
             </a:fld>
             <a:endParaRPr lang="it-IT" dirty="0"/>
           </a:p>
@@ -13209,8 +13209,8 @@
         </p:nvSpPr>
         <p:spPr>
           <a:xfrm>
-            <a:off x="4204864" y="1741431"/>
-            <a:ext cx="7303175" cy="4324261"/>
+            <a:off x="3988905" y="1454451"/>
+            <a:ext cx="7518129" cy="4524315"/>
           </a:xfrm>
           <a:prstGeom prst="rect">
             <a:avLst/>
@@ -13225,19 +13225,39 @@
           <a:p>
             <a:pPr algn="r"/>
             <a:r>
-              <a:rPr lang="en-US" sz="2500" i="0" dirty="0">
+              <a:rPr lang="en-US" i="0" dirty="0">
                 <a:solidFill>
                   <a:srgbClr val="F0F6FC"/>
                 </a:solidFill>
                 <a:effectLst/>
                 <a:latin typeface="-apple-system"/>
               </a:rPr>
-              <a:t>For testing and demonstration purposes, the application includes a custom Python script that generates synthetic DNS data specifically for the app’s proof of concept. </a:t>
+              <a:t>For testing and demonstration purposes, the application includes a custom Python script that generates </a:t>
+            </a:r>
+            <a:r>
+              <a:rPr lang="en-US" b="1" i="0" dirty="0">
+                <a:solidFill>
+                  <a:srgbClr val="F0F6FC"/>
+                </a:solidFill>
+                <a:effectLst/>
+                <a:latin typeface="-apple-system"/>
+              </a:rPr>
+              <a:t>synthetic DNS data</a:t>
+            </a:r>
+            <a:r>
+              <a:rPr lang="en-US" i="0" dirty="0">
+                <a:solidFill>
+                  <a:srgbClr val="F0F6FC"/>
+                </a:solidFill>
+                <a:effectLst/>
+                <a:latin typeface="-apple-system"/>
+              </a:rPr>
+              <a:t> specifically for the app’s proof of concept. </a:t>
             </a:r>
           </a:p>
           <a:p>
             <a:pPr algn="r"/>
-            <a:endParaRPr lang="en-US" sz="2500" dirty="0">
+            <a:endParaRPr lang="en-US" dirty="0">
               <a:solidFill>
                 <a:srgbClr val="F0F6FC"/>
               </a:solidFill>
@@ -13247,7 +13267,7 @@
           <a:p>
             <a:pPr algn="r"/>
             <a:r>
-              <a:rPr lang="en-US" sz="2500" i="0" dirty="0">
+              <a:rPr lang="en-US" i="0" dirty="0">
                 <a:solidFill>
                   <a:srgbClr val="F0F6FC"/>
                 </a:solidFill>
@@ -13257,7 +13277,7 @@
               <a:t>The generated events adhere to the </a:t>
             </a:r>
             <a:r>
-              <a:rPr lang="en-US" sz="2500" b="1" i="0" dirty="0">
+              <a:rPr lang="en-US" b="1" i="0" dirty="0">
                 <a:solidFill>
                   <a:srgbClr val="F0F6FC"/>
                 </a:solidFill>
@@ -13267,7 +13287,7 @@
               <a:t>Common Information Model (CIM)</a:t>
             </a:r>
             <a:r>
-              <a:rPr lang="en-US" sz="2500" i="0" dirty="0">
+              <a:rPr lang="en-US" i="0" dirty="0">
                 <a:solidFill>
                   <a:srgbClr val="F0F6FC"/>
                 </a:solidFill>
@@ -13277,26 +13297,148 @@
               <a:t>, particularly the </a:t>
             </a:r>
             <a:r>
-              <a:rPr lang="en-US" sz="2500" b="1" i="0" dirty="0">
+              <a:rPr lang="en-US" b="1" i="0" dirty="0">
                 <a:solidFill>
                   <a:srgbClr val="F0F6FC"/>
                 </a:solidFill>
                 <a:effectLst/>
                 <a:latin typeface="-apple-system"/>
               </a:rPr>
-              <a:t>Network Resolution</a:t>
-            </a:r>
-            <a:r>
-              <a:rPr lang="en-US" sz="2500" i="0" dirty="0">
+              <a:t>Network Resolution data model</a:t>
+            </a:r>
+            <a:r>
+              <a:rPr lang="en-US" i="0" dirty="0">
                 <a:solidFill>
                   <a:srgbClr val="F0F6FC"/>
                 </a:solidFill>
                 <a:effectLst/>
                 <a:latin typeface="-apple-system"/>
               </a:rPr>
-              <a:t> data model, ensuring compatibility with Splunk’s detection and enrichment features. The synthetic dataset simulates a wide range of DNS anomalies</a:t>
-            </a:r>
-            <a:endParaRPr lang="it-IT" sz="2500" dirty="0">
+              <a:t>, ensuring compatibility with Splunk’s detection and enrichment features. The synthetic dataset simulates a wide range of DNS anomalies and represents a realistic stream of network activity within an enterprise environment. </a:t>
+            </a:r>
+          </a:p>
+          <a:p>
+            <a:pPr algn="r"/>
+            <a:endParaRPr lang="en-US" dirty="0">
+              <a:solidFill>
+                <a:srgbClr val="F0F6FC"/>
+              </a:solidFill>
+              <a:latin typeface="-apple-system"/>
+            </a:endParaRPr>
+          </a:p>
+          <a:p>
+            <a:pPr algn="r"/>
+            <a:r>
+              <a:rPr lang="en-US" i="0" dirty="0">
+                <a:solidFill>
+                  <a:srgbClr val="F0F6FC"/>
+                </a:solidFill>
+                <a:effectLst/>
+                <a:latin typeface="-apple-system"/>
+              </a:rPr>
+              <a:t>It includes both benign and malicious DNS behavior to mirror real-world scenarios, making it ideal for evaluating the app’s detection capabilities. These events cover various anomaly types such as </a:t>
+            </a:r>
+            <a:r>
+              <a:rPr lang="en-US" b="1" i="0" dirty="0">
+                <a:solidFill>
+                  <a:srgbClr val="F0F6FC"/>
+                </a:solidFill>
+                <a:effectLst/>
+                <a:latin typeface="-apple-system"/>
+              </a:rPr>
+              <a:t>beaconing</a:t>
+            </a:r>
+            <a:r>
+              <a:rPr lang="en-US" i="0" dirty="0">
+                <a:solidFill>
+                  <a:srgbClr val="F0F6FC"/>
+                </a:solidFill>
+                <a:effectLst/>
+                <a:latin typeface="-apple-system"/>
+              </a:rPr>
+              <a:t>, </a:t>
+            </a:r>
+            <a:r>
+              <a:rPr lang="en-US" b="1" i="0" dirty="0">
+                <a:solidFill>
+                  <a:srgbClr val="F0F6FC"/>
+                </a:solidFill>
+                <a:effectLst/>
+                <a:latin typeface="-apple-system"/>
+              </a:rPr>
+              <a:t>C2 tunneling</a:t>
+            </a:r>
+            <a:r>
+              <a:rPr lang="en-US" i="0" dirty="0">
+                <a:solidFill>
+                  <a:srgbClr val="F0F6FC"/>
+                </a:solidFill>
+                <a:effectLst/>
+                <a:latin typeface="-apple-system"/>
+              </a:rPr>
+              <a:t>, </a:t>
+            </a:r>
+            <a:r>
+              <a:rPr lang="en-US" b="1" i="0" dirty="0">
+                <a:solidFill>
+                  <a:srgbClr val="F0F6FC"/>
+                </a:solidFill>
+                <a:effectLst/>
+                <a:latin typeface="-apple-system"/>
+              </a:rPr>
+              <a:t>excessive query lengths</a:t>
+            </a:r>
+            <a:r>
+              <a:rPr lang="en-US" i="0" dirty="0">
+                <a:solidFill>
+                  <a:srgbClr val="F0F6FC"/>
+                </a:solidFill>
+                <a:effectLst/>
+                <a:latin typeface="-apple-system"/>
+              </a:rPr>
+              <a:t>, </a:t>
+            </a:r>
+            <a:r>
+              <a:rPr lang="en-US" b="1" i="0" dirty="0">
+                <a:solidFill>
+                  <a:srgbClr val="F0F6FC"/>
+                </a:solidFill>
+                <a:effectLst/>
+                <a:latin typeface="-apple-system"/>
+              </a:rPr>
+              <a:t>rare DNS record types</a:t>
+            </a:r>
+            <a:r>
+              <a:rPr lang="en-US" i="0" dirty="0">
+                <a:solidFill>
+                  <a:srgbClr val="F0F6FC"/>
+                </a:solidFill>
+                <a:effectLst/>
+                <a:latin typeface="-apple-system"/>
+              </a:rPr>
+              <a:t> (e.g., ANY, HINFO, AXFR), and </a:t>
+            </a:r>
+            <a:r>
+              <a:rPr lang="en-US" b="1" i="0" dirty="0">
+                <a:solidFill>
+                  <a:srgbClr val="F0F6FC"/>
+                </a:solidFill>
+                <a:effectLst/>
+                <a:latin typeface="-apple-system"/>
+              </a:rPr>
+              <a:t>domain shadowing</a:t>
+            </a:r>
+            <a:r>
+              <a:rPr lang="en-US" i="0" dirty="0">
+                <a:solidFill>
+                  <a:srgbClr val="F0F6FC"/>
+                </a:solidFill>
+                <a:effectLst/>
+                <a:latin typeface="-apple-system"/>
+              </a:rPr>
+              <a:t>—allowing for thorough testing of detection logic under controlled yet representative conditions.</a:t>
+            </a:r>
+            <a:endParaRPr lang="it-IT" dirty="0">
               <a:solidFill>
                 <a:schemeClr val="bg1"/>
               </a:solidFill>

</xml_diff>